<commit_message>
feat(CR-040): username theo ten that, auto-suggest + doi ten tai khoan demo
- src/lib/username.ts: usernameBase (bo dau, ten + viet tat ho dem) +
  suggestUsername (hau to so khi trung) + unit tests
- /school/users: go ho ten -> tu de xuat email @<domain truong>, sua tay duoc
- bootstrap-school.mjs: can_bo.email trong -> tu sinh + dedupe, them --domain
- rename-demo-accounts.mjs: doi 88 tai khoan demo prod sang quy uoc moi
  (gvcn@demo.scn -> anhptl@nd.scn...), admin giu nguyen
- email.ts + cron parent-digest: block moi *.scn (parent contacts la @mail.scn,
  block @demo.scn cu khong con cover)
- template xlsx + seed + 20 file docs/QA cap nhat email moi; regen pptx/docx

Generated with [Devin](https://devin.ai)

Co-Authored-By: Devin <158243242+devin-ai-integration[bot]@users.noreply.github.com>
</commit_message>
<xml_diff>
--- a/docs/handover/KICH-BAN-DEMO.pptx
+++ b/docs/handover/KICH-BAN-DEMO.pptx
@@ -2289,7 +2289,7 @@
                 <a:ea typeface="Segoe UI" pitchFamily="34" charset="-122"/>
                 <a:cs typeface="Segoe UI" pitchFamily="34" charset="-120"/>
               </a:rPr>
-              <a:t>phuhuynh@demo.scn, hocsinh@demo.scn</a:t>
+              <a:t>annv@nd.scn, baong@nd.scn</a:t>
             </a:r>
             <a:endParaRPr lang="en-US" sz="2600" dirty="0"/>
           </a:p>
@@ -2662,7 +2662,7 @@
                 <a:ea typeface="Segoe UI" pitchFamily="34" charset="-122"/>
                 <a:cs typeface="Segoe UI" pitchFamily="34" charset="-120"/>
               </a:rPr>
-              <a:t>sogd, ubnd, gvcn.cva</a:t>
+              <a:t>sovqt, daonvl, oanhdtk</a:t>
             </a:r>
             <a:endParaRPr lang="en-US" sz="2600" dirty="0"/>
           </a:p>
@@ -2767,7 +2767,7 @@
                 <a:ea typeface="Segoe UI" pitchFamily="34" charset="-122"/>
                 <a:cs typeface="Segoe UI" pitchFamily="34" charset="-120"/>
               </a:rPr>
-              <a:t>E1. Sở GD&amp;ĐT (sogd@demo.scn)</a:t>
+              <a:t>E1. Sở GD&amp;ĐT (sovqt@demo.scn)</a:t>
             </a:r>
             <a:endParaRPr lang="en-US" sz="1350" dirty="0"/>
           </a:p>
@@ -2830,7 +2830,7 @@
                 <a:ea typeface="Segoe UI" pitchFamily="34" charset="-122"/>
                 <a:cs typeface="Segoe UI" pitchFamily="34" charset="-120"/>
               </a:rPr>
-              <a:t>E2. UBND (ubnd@demo.scn)</a:t>
+              <a:t>E2. UBND (daonvl@demo.scn)</a:t>
             </a:r>
             <a:endParaRPr lang="en-US" sz="1350" dirty="0"/>
           </a:p>
@@ -2872,7 +2872,7 @@
                 <a:ea typeface="Segoe UI" pitchFamily="34" charset="-122"/>
                 <a:cs typeface="Segoe UI" pitchFamily="34" charset="-120"/>
               </a:rPr>
-              <a:t>F1. Tiểu học Chu Văn An (gvcn.cva@demo.scn)</a:t>
+              <a:t>F1. Tiểu học Chu Văn An (oanhdtk@cva.scn)</a:t>
             </a:r>
             <a:endParaRPr lang="en-US" sz="1350" dirty="0"/>
           </a:p>
@@ -3467,7 +3467,7 @@
                           <a:ea typeface="Segoe UI" pitchFamily="34" charset="-122"/>
                           <a:cs typeface="Segoe UI" pitchFamily="34" charset="-120"/>
                         </a:rPr>
-                        <a:t>bgh.cva@demo.scn mở URL chức năng trường ND</a:t>
+                        <a:t>phuongttm@cva.scn mở URL chức năng trường ND</a:t>
                       </a:r>
                       <a:endParaRPr lang="en-US" sz="1050" dirty="0">
                         <a:latin typeface="Segoe UI" charset="0"/>
@@ -3673,7 +3673,7 @@
                           <a:ea typeface="Segoe UI" pitchFamily="34" charset="-122"/>
                           <a:cs typeface="Segoe UI" pitchFamily="34" charset="-120"/>
                         </a:rPr>
-                        <a:t>pht@demo.scn xem danh sách lớp</a:t>
+                        <a:t>duclm@nd.scn xem danh sách lớp</a:t>
                       </a:r>
                       <a:endParaRPr lang="en-US" sz="1050" dirty="0">
                         <a:latin typeface="Segoe UI" charset="0"/>
@@ -3879,7 +3879,7 @@
                           <a:ea typeface="Segoe UI" pitchFamily="34" charset="-122"/>
                           <a:cs typeface="Segoe UI" pitchFamily="34" charset="-120"/>
                         </a:rPr>
-                        <a:t>gvbm@demo.scn vào route chủ nhiệm</a:t>
+                        <a:t>minhtv@nd.scn vào route chủ nhiệm</a:t>
                       </a:r>
                       <a:endParaRPr lang="en-US" sz="1050" dirty="0">
                         <a:latin typeface="Segoe UI" charset="0"/>
@@ -4085,7 +4085,7 @@
                           <a:ea typeface="Segoe UI" pitchFamily="34" charset="-122"/>
                           <a:cs typeface="Segoe UI" pitchFamily="34" charset="-120"/>
                         </a:rPr>
-                        <a:t>phuhuynh@demo.scn</a:t>
+                        <a:t>annv@nd.scn</a:t>
                       </a:r>
                       <a:endParaRPr lang="en-US" sz="1050" dirty="0">
                         <a:latin typeface="Segoe UI" charset="0"/>
@@ -4291,7 +4291,7 @@
                           <a:ea typeface="Segoe UI" pitchFamily="34" charset="-122"/>
                           <a:cs typeface="Segoe UI" pitchFamily="34" charset="-120"/>
                         </a:rPr>
-                        <a:t>ubnd@demo.scn</a:t>
+                        <a:t>daonvl@demo.scn</a:t>
                       </a:r>
                       <a:endParaRPr lang="en-US" sz="1050" dirty="0">
                         <a:latin typeface="Segoe UI" charset="0"/>
@@ -7515,7 +7515,7 @@
                 <a:ea typeface="Segoe UI" pitchFamily="34" charset="-122"/>
                 <a:cs typeface="Segoe UI" pitchFamily="34" charset="-120"/>
               </a:rPr>
-              <a:t>Tài khoản chính của THCS Nguyễn Du (trường khác: hậu tố .cva / .kd)</a:t>
+              <a:t>Tài khoản chính của THCS Nguyễn Du (trường khác: @cva.scn / @kd.scn)</a:t>
             </a:r>
             <a:endParaRPr lang="en-US" sz="1250" dirty="0"/>
           </a:p>
@@ -7863,7 +7863,7 @@
                           <a:ea typeface="Segoe UI" pitchFamily="34" charset="-122"/>
                           <a:cs typeface="Segoe UI" pitchFamily="34" charset="-120"/>
                         </a:rPr>
-                        <a:t>bgh@demo.scn</a:t>
+                        <a:t>hainv@nd.scn</a:t>
                       </a:r>
                       <a:endParaRPr lang="en-US" sz="1050" dirty="0">
                         <a:latin typeface="Segoe UI" charset="0"/>
@@ -8069,7 +8069,7 @@
                           <a:ea typeface="Segoe UI" pitchFamily="34" charset="-122"/>
                           <a:cs typeface="Segoe UI" pitchFamily="34" charset="-120"/>
                         </a:rPr>
-                        <a:t>pht@demo.scn</a:t>
+                        <a:t>duclm@nd.scn</a:t>
                       </a:r>
                       <a:endParaRPr lang="en-US" sz="1050" dirty="0">
                         <a:latin typeface="Segoe UI" charset="0"/>
@@ -8275,7 +8275,7 @@
                           <a:ea typeface="Segoe UI" pitchFamily="34" charset="-122"/>
                           <a:cs typeface="Segoe UI" pitchFamily="34" charset="-120"/>
                         </a:rPr>
-                        <a:t>totruong@demo.scn</a:t>
+                        <a:t>hanhlth@nd.scn</a:t>
                       </a:r>
                       <a:endParaRPr lang="en-US" sz="1050" dirty="0">
                         <a:latin typeface="Segoe UI" charset="0"/>
@@ -8481,7 +8481,7 @@
                           <a:ea typeface="Segoe UI" pitchFamily="34" charset="-122"/>
                           <a:cs typeface="Segoe UI" pitchFamily="34" charset="-120"/>
                         </a:rPr>
-                        <a:t>gvcn@demo.scn</a:t>
+                        <a:t>anhptl@nd.scn</a:t>
                       </a:r>
                       <a:endParaRPr lang="en-US" sz="1050" dirty="0">
                         <a:latin typeface="Segoe UI" charset="0"/>
@@ -8687,7 +8687,7 @@
                           <a:ea typeface="Segoe UI" pitchFamily="34" charset="-122"/>
                           <a:cs typeface="Segoe UI" pitchFamily="34" charset="-120"/>
                         </a:rPr>
-                        <a:t>gvbm@demo.scn</a:t>
+                        <a:t>minhtv@nd.scn</a:t>
                       </a:r>
                       <a:endParaRPr lang="en-US" sz="1050" dirty="0">
                         <a:latin typeface="Segoe UI" charset="0"/>
@@ -8893,7 +8893,7 @@
                           <a:ea typeface="Segoe UI" pitchFamily="34" charset="-122"/>
                           <a:cs typeface="Segoe UI" pitchFamily="34" charset="-120"/>
                         </a:rPr>
-                        <a:t>ketoan@demo.scn</a:t>
+                        <a:t>trangpt@nd.scn</a:t>
                       </a:r>
                       <a:endParaRPr lang="en-US" sz="1050" dirty="0">
                         <a:latin typeface="Segoe UI" charset="0"/>
@@ -9099,7 +9099,7 @@
                           <a:ea typeface="Segoe UI" pitchFamily="34" charset="-122"/>
                           <a:cs typeface="Segoe UI" pitchFamily="34" charset="-120"/>
                         </a:rPr>
-                        <a:t>phuhuynh@demo.scn</a:t>
+                        <a:t>annv@nd.scn</a:t>
                       </a:r>
                       <a:endParaRPr lang="en-US" sz="1050" dirty="0">
                         <a:latin typeface="Segoe UI" charset="0"/>
@@ -9305,7 +9305,7 @@
                           <a:ea typeface="Segoe UI" pitchFamily="34" charset="-122"/>
                           <a:cs typeface="Segoe UI" pitchFamily="34" charset="-120"/>
                         </a:rPr>
-                        <a:t>hocsinh@demo.scn</a:t>
+                        <a:t>baong@nd.scn</a:t>
                       </a:r>
                       <a:endParaRPr lang="en-US" sz="1050" dirty="0">
                         <a:latin typeface="Segoe UI" charset="0"/>
@@ -9511,7 +9511,7 @@
                           <a:ea typeface="Segoe UI" pitchFamily="34" charset="-122"/>
                           <a:cs typeface="Segoe UI" pitchFamily="34" charset="-120"/>
                         </a:rPr>
-                        <a:t>sogd@demo.scn</a:t>
+                        <a:t>sovqt@demo.scn</a:t>
                       </a:r>
                       <a:endParaRPr lang="en-US" sz="1050" dirty="0">
                         <a:latin typeface="Segoe UI" charset="0"/>
@@ -9717,7 +9717,7 @@
                           <a:ea typeface="Segoe UI" pitchFamily="34" charset="-122"/>
                           <a:cs typeface="Segoe UI" pitchFamily="34" charset="-120"/>
                         </a:rPr>
-                        <a:t>ubnd@demo.scn</a:t>
+                        <a:t>daonvl@demo.scn</a:t>
                       </a:r>
                       <a:endParaRPr lang="en-US" sz="1050" dirty="0">
                         <a:latin typeface="Segoe UI" charset="0"/>
@@ -10562,7 +10562,7 @@
                 <a:ea typeface="Segoe UI" pitchFamily="34" charset="-122"/>
                 <a:cs typeface="Segoe UI" pitchFamily="34" charset="-120"/>
               </a:rPr>
-              <a:t>gvcn@demo.scn - cô Phạm Thị Lan Anh, lớp 8A2</a:t>
+              <a:t>anhptl@nd.scn - cô Phạm Thị Lan Anh, lớp 8A2</a:t>
             </a:r>
             <a:endParaRPr lang="en-US" sz="2600" dirty="0"/>
           </a:p>
@@ -11416,7 +11416,7 @@
                 <a:ea typeface="Segoe UI" pitchFamily="34" charset="-122"/>
                 <a:cs typeface="Segoe UI" pitchFamily="34" charset="-120"/>
               </a:rPr>
-              <a:t>totruong@demo.scn rồi bgh@demo.scn</a:t>
+              <a:t>hanhlth@nd.scn rồi hainv@nd.scn</a:t>
             </a:r>
             <a:endParaRPr lang="en-US" sz="2600" dirty="0"/>
           </a:p>
@@ -11813,7 +11813,7 @@
                 <a:ea typeface="Segoe UI" pitchFamily="34" charset="-122"/>
                 <a:cs typeface="Segoe UI" pitchFamily="34" charset="-120"/>
               </a:rPr>
-              <a:t>bgh@demo.scn + đối chứng pht@demo.scn</a:t>
+              <a:t>hainv@nd.scn + đối chứng duclm@nd.scn</a:t>
             </a:r>
             <a:endParaRPr lang="en-US" sz="2600" dirty="0"/>
           </a:p>
@@ -12044,7 +12044,7 @@
                 <a:ea typeface="Segoe UI" pitchFamily="34" charset="-122"/>
                 <a:cs typeface="Segoe UI" pitchFamily="34" charset="-120"/>
               </a:rPr>
-              <a:t>3. Đối chứng PHT (đổi tài khoản pht@demo.scn)</a:t>
+              <a:t>3. Đối chứng PHT (đổi tài khoản duclm@nd.scn)</a:t>
             </a:r>
             <a:endParaRPr lang="en-US" sz="1350" dirty="0"/>
           </a:p>

</xml_diff>

<commit_message>
docs: merge user guide + intro into single PPTX, refresh demo script for 15-10
- gen-user-guide-pptx.mjs now emits the single consolidated deck
  (guide + feature intro + screenshots) to docs/user-guide/ and copies
  to docs/handover/ - absorbs retired SO-CHU-NHIEM-SO-GIOI-THIEU.pptx
- gen-user-docs.py reduced to DOCX-only output
- KICH-BAN-DEMO: added Luong H (Studio TVC360) incl. A-03 audio demo
  account; bumped to v2.0 for the 15/10 demo; pptx now 15 slides
- MO-TA-CHUC-NANG/HUONG-DAN: fixed stale theta.vercel.app URL to prod,
  bumped versions
- data fix: removed stale second audio block (included exercise lines)
  from A-03 demo material edf876b3 + deleted wrong mp3 from tvc-media

Generated with [Devin](https://devin.ai)

Co-Authored-By: Devin <158243242+devin-ai-integration[bot]@users.noreply.github.com>
</commit_message>
<xml_diff>
--- a/docs/handover/KICH-BAN-DEMO.pptx
+++ b/docs/handover/KICH-BAN-DEMO.pptx
@@ -19,9 +19,10 @@
     <p:sldId id="267" r:id="rId13"/>
     <p:sldId id="268" r:id="rId14"/>
     <p:sldId id="269" r:id="rId15"/>
+    <p:sldId id="270" r:id="rId16"/>
   </p:sldIdLst>
   <p:notesMasterIdLst>
-    <p:notesMasterId r:id="rId16"/>
+    <p:notesMasterId r:id="rId17"/>
   </p:notesMasterIdLst>
   <p:sldSz cx="12188952" cy="6858000"/>
   <p:notesSz cx="6858000" cy="12188952"/>
@@ -979,6 +980,94 @@
             <a:fld id="{F7021451-1387-4CA6-816F-3879F97B5CBC}" type="slidenum">
               <a:rPr lang="en-US"/>
               <a:t>14</a:t>
+            </a:fld>
+            <a:endParaRPr lang="en-US"/>
+          </a:p>
+        </p:txBody>
+      </p:sp>
+    </p:spTree>
+    <p:extLst>
+      <p:ext uri="{BB962C8B-B14F-4D97-AF65-F5344CB8AC3E}">
+        <p14:creationId xmlns:p14="http://schemas.microsoft.com/office/powerpoint/2010/main" val="1024086991"/>
+      </p:ext>
+    </p:extLst>
+  </p:cSld>
+  <p:clrMapOvr>
+    <a:masterClrMapping/>
+  </p:clrMapOvr>
+</p:notes>
+</file>
+
+<file path=ppt/notesSlides/notesSlide15.xml><?xml version="1.0" encoding="utf-8"?>
+<p:notes xmlns:a="http://schemas.openxmlformats.org/drawingml/2006/main" xmlns:r="http://schemas.openxmlformats.org/officeDocument/2006/relationships" xmlns:p="http://schemas.openxmlformats.org/presentationml/2006/main">
+  <p:cSld>
+    <p:spTree>
+      <p:nvGrpSpPr>
+        <p:cNvPr id="1" name=""/>
+        <p:cNvGrpSpPr/>
+        <p:nvPr/>
+      </p:nvGrpSpPr>
+      <p:grpSpPr>
+        <a:xfrm>
+          <a:off x="0" y="0"/>
+          <a:ext cx="0" cy="0"/>
+          <a:chOff x="0" y="0"/>
+          <a:chExt cx="0" cy="0"/>
+        </a:xfrm>
+      </p:grpSpPr>
+      <p:sp>
+        <p:nvSpPr>
+          <p:cNvPr id="2" name="Slide Image Placeholder 1"/>
+          <p:cNvSpPr>
+            <a:spLocks noGrp="1" noRot="1" noChangeAspect="1"/>
+          </p:cNvSpPr>
+          <p:nvPr>
+            <p:ph type="sldImg"/>
+          </p:nvPr>
+        </p:nvSpPr>
+        <p:spPr/>
+      </p:sp>
+      <p:sp>
+        <p:nvSpPr>
+          <p:cNvPr id="3" name="Notes Placeholder 2"/>
+          <p:cNvSpPr>
+            <a:spLocks noGrp="1"/>
+          </p:cNvSpPr>
+          <p:nvPr>
+            <p:ph type="body" idx="1"/>
+          </p:nvPr>
+        </p:nvSpPr>
+        <p:spPr/>
+        <p:txBody>
+          <a:bodyPr/>
+          <a:lstStyle/>
+          <a:p>
+            <a:r>
+              <a:rPr lang="en-US" dirty="0"/>
+              <a:t/>
+            </a:r>
+            <a:endParaRPr lang="en-US" dirty="0"/>
+          </a:p>
+        </p:txBody>
+      </p:sp>
+      <p:sp>
+        <p:nvSpPr>
+          <p:cNvPr id="4" name="Slide Number Placeholder 3"/>
+          <p:cNvSpPr>
+            <a:spLocks noGrp="1"/>
+          </p:cNvSpPr>
+          <p:nvPr>
+            <p:ph type="sldNum" sz="quarter" idx="10"/>
+          </p:nvPr>
+        </p:nvSpPr>
+        <p:spPr/>
+        <p:txBody>
+          <a:bodyPr/>
+          <a:lstStyle/>
+          <a:p>
+            <a:fld id="{F7021451-1387-4CA6-816F-3879F97B5CBC}" type="slidenum">
+              <a:rPr lang="en-US"/>
+              <a:t>15</a:t>
             </a:fld>
             <a:endParaRPr lang="en-US"/>
           </a:p>
@@ -2057,7 +2146,7 @@
               <a:buNone/>
             </a:pPr>
             <a:r>
-              <a:rPr lang="en-US" sz="3400" b="1" dirty="0">
+              <a:rPr lang="en-US" sz="3200" b="1" dirty="0">
                 <a:solidFill>
                   <a:srgbClr val="FFFFFF"/>
                 </a:solidFill>
@@ -2065,9 +2154,9 @@
                 <a:ea typeface="Segoe UI" pitchFamily="34" charset="-122"/>
                 <a:cs typeface="Segoe UI" pitchFamily="34" charset="-120"/>
               </a:rPr>
-              <a:t>KỊCH BẢN DEMO - SỔ CHỦ NHIỆM SỐ</a:t>
-            </a:r>
-            <a:endParaRPr lang="en-US" sz="3400" dirty="0"/>
+              <a:t>KỊCH BẢN DEMO - SỔ CHỦ NHIỆM SỐ &amp; CÔNG CỤ SỐ GIÁO VIÊN</a:t>
+            </a:r>
+            <a:endParaRPr lang="en-US" sz="3200" dirty="0"/>
           </a:p>
         </p:txBody>
       </p:sp>
@@ -2104,7 +2193,7 @@
                 <a:ea typeface="Segoe UI" pitchFamily="34" charset="-122"/>
                 <a:cs typeface="Segoe UI" pitchFamily="34" charset="-120"/>
               </a:rPr>
-              <a:t>Nền tảng số hóa công tác chủ nhiệm &amp; công cụ giáo viên - VieSchool</a:t>
+              <a:t>Một nền tảng: số hóa công tác chủ nhiệm + Studio TVC360 tích hợp - VieSchool</a:t>
             </a:r>
             <a:endParaRPr lang="en-US" sz="1500" dirty="0"/>
           </a:p>
@@ -2186,7 +2275,7 @@
                 <a:ea typeface="Segoe UI" pitchFamily="34" charset="-122"/>
                 <a:cs typeface="Segoe UI" pitchFamily="34" charset="-120"/>
               </a:rPr>
-              <a:t>Phiên bản: 10/2026 - CR-036 (data thật) + CR-038 (vai trò kiêm nhiệm)</a:t>
+              <a:t>Phiên bản: demo 15/10/2026 - data thật + vai trò kiêm nhiệm + Studio (A-03 audio, ngân hàng đã dọn trùng)</a:t>
             </a:r>
             <a:endParaRPr lang="en-US" sz="1300" dirty="0"/>
           </a:p>
@@ -3041,6 +3130,484 @@
                 <a:ea typeface="Segoe UI" pitchFamily="34" charset="-122"/>
                 <a:cs typeface="Segoe UI" pitchFamily="34" charset="-120"/>
               </a:rPr>
+              <a:t>LUỒNG H - STUDIO CÔNG CỤ SỐ (TVC360)</a:t>
+            </a:r>
+            <a:endParaRPr lang="en-US" sz="1100" dirty="0"/>
+          </a:p>
+        </p:txBody>
+      </p:sp>
+      <p:sp>
+        <p:nvSpPr>
+          <p:cNvPr id="3" name="Text 1"/>
+          <p:cNvSpPr/>
+          <p:nvPr/>
+        </p:nvSpPr>
+        <p:spPr>
+          <a:xfrm>
+            <a:off x="502920" y="502920"/>
+            <a:ext cx="11155680" cy="640080"/>
+          </a:xfrm>
+          <a:prstGeom prst="rect">
+            <a:avLst/>
+          </a:prstGeom>
+          <a:noFill/>
+          <a:ln/>
+        </p:spPr>
+        <p:txBody>
+          <a:bodyPr wrap="square" rtlCol="0" anchor="ctr"/>
+          <a:lstStyle/>
+          <a:p>
+            <a:pPr indent="0" marL="0">
+              <a:buNone/>
+            </a:pPr>
+            <a:r>
+              <a:rPr lang="en-US" sz="2600" b="1" dirty="0">
+                <a:solidFill>
+                  <a:srgbClr val="0F172A"/>
+                </a:solidFill>
+                <a:latin typeface="Segoe UI" pitchFamily="34" charset="0"/>
+                <a:ea typeface="Segoe UI" pitchFamily="34" charset="-122"/>
+                <a:cs typeface="Segoe UI" pitchFamily="34" charset="-120"/>
+              </a:rPr>
+              <a:t>minhtv@nd.scn hoặc anhptl@nd.scn - /studio trong cùng app</a:t>
+            </a:r>
+            <a:endParaRPr lang="en-US" sz="2600" dirty="0"/>
+          </a:p>
+        </p:txBody>
+      </p:sp>
+      <p:sp>
+        <p:nvSpPr>
+          <p:cNvPr id="4" name="Text 2"/>
+          <p:cNvSpPr/>
+          <p:nvPr/>
+        </p:nvSpPr>
+        <p:spPr>
+          <a:xfrm>
+            <a:off x="502920" y="1170432"/>
+            <a:ext cx="11155680" cy="411480"/>
+          </a:xfrm>
+          <a:prstGeom prst="rect">
+            <a:avLst/>
+          </a:prstGeom>
+          <a:noFill/>
+          <a:ln/>
+        </p:spPr>
+        <p:txBody>
+          <a:bodyPr wrap="square" rtlCol="0" anchor="ctr"/>
+          <a:lstStyle/>
+          <a:p>
+            <a:pPr indent="0" marL="0">
+              <a:buNone/>
+            </a:pPr>
+            <a:r>
+              <a:rPr lang="en-US" sz="1250" dirty="0">
+                <a:solidFill>
+                  <a:srgbClr val="475569"/>
+                </a:solidFill>
+                <a:latin typeface="Segoe UI" pitchFamily="34" charset="0"/>
+                <a:ea typeface="Segoe UI" pitchFamily="34" charset="-122"/>
+                <a:cs typeface="Segoe UI" pitchFamily="34" charset="-120"/>
+              </a:rPr>
+              <a:t>~5 phút - chứng minh 2 module trên một nền tảng</a:t>
+            </a:r>
+            <a:endParaRPr lang="en-US" sz="1250" dirty="0"/>
+          </a:p>
+        </p:txBody>
+      </p:sp>
+      <p:sp>
+        <p:nvSpPr>
+          <p:cNvPr id="5" name="Shape 3"/>
+          <p:cNvSpPr/>
+          <p:nvPr/>
+        </p:nvSpPr>
+        <p:spPr>
+          <a:xfrm>
+            <a:off x="502920" y="1572768"/>
+            <a:ext cx="11155680" cy="0"/>
+          </a:xfrm>
+          <a:prstGeom prst="line">
+            <a:avLst/>
+          </a:prstGeom>
+          <a:noFill/>
+          <a:ln w="12700">
+            <a:solidFill>
+              <a:srgbClr val="E2E8F0"/>
+            </a:solidFill>
+            <a:prstDash val="solid"/>
+          </a:ln>
+        </p:spPr>
+      </p:sp>
+      <p:sp>
+        <p:nvSpPr>
+          <p:cNvPr id="6" name="Text 4"/>
+          <p:cNvSpPr/>
+          <p:nvPr/>
+        </p:nvSpPr>
+        <p:spPr>
+          <a:xfrm>
+            <a:off x="640080" y="1783080"/>
+            <a:ext cx="10972800" cy="4572000"/>
+          </a:xfrm>
+          <a:prstGeom prst="rect">
+            <a:avLst/>
+          </a:prstGeom>
+          <a:noFill/>
+          <a:ln/>
+        </p:spPr>
+        <p:txBody>
+          <a:bodyPr wrap="square" rtlCol="0" anchor="t"/>
+          <a:lstStyle/>
+          <a:p>
+            <a:pPr marL="177800" indent="-177800">
+              <a:spcAft>
+                <a:spcPts val="800"/>
+              </a:spcAft>
+              <a:buSzPct val="100000"/>
+              <a:buChar char="•"/>
+            </a:pPr>
+            <a:r>
+              <a:rPr lang="en-US" sz="1350" b="1" dirty="0">
+                <a:solidFill>
+                  <a:srgbClr val="0F172A"/>
+                </a:solidFill>
+                <a:latin typeface="Segoe UI" pitchFamily="34" charset="0"/>
+                <a:ea typeface="Segoe UI" pitchFamily="34" charset="-122"/>
+                <a:cs typeface="Segoe UI" pitchFamily="34" charset="-120"/>
+              </a:rPr>
+              <a:t>1. Tất cả công cụ (/studio)</a:t>
+            </a:r>
+            <a:endParaRPr lang="en-US" sz="1350" dirty="0"/>
+          </a:p>
+          <a:p>
+            <a:pPr marL="381000" indent="-381000">
+              <a:spcAft>
+                <a:spcPts val="800"/>
+              </a:spcAft>
+              <a:buSzPct val="100000"/>
+              <a:buChar char="–"/>
+            </a:pPr>
+            <a:r>
+              <a:rPr lang="en-US" sz="1200" dirty="0">
+                <a:solidFill>
+                  <a:srgbClr val="475569"/>
+                </a:solidFill>
+                <a:latin typeface="Segoe UI" pitchFamily="34" charset="0"/>
+                <a:ea typeface="Segoe UI" pitchFamily="34" charset="-122"/>
+                <a:cs typeface="Segoe UI" pitchFamily="34" charset="-120"/>
+              </a:rPr>
+              <a:t>Nhóm DC-01..06: KHBĐ CV 5512, ma trận đề, đề kiểm tra, bộ câu hỏi, phiếu học tập, bài trình chiếu</a:t>
+            </a:r>
+            <a:endParaRPr lang="en-US" sz="1350" dirty="0"/>
+          </a:p>
+          <a:p>
+            <a:pPr marL="381000" indent="-381000">
+              <a:spcAft>
+                <a:spcPts val="800"/>
+              </a:spcAft>
+              <a:buSzPct val="100000"/>
+              <a:buChar char="–"/>
+            </a:pPr>
+            <a:r>
+              <a:rPr lang="en-US" sz="1200" dirty="0">
+                <a:solidFill>
+                  <a:srgbClr val="475569"/>
+                </a:solidFill>
+                <a:latin typeface="Segoe UI" pitchFamily="34" charset="0"/>
+                <a:ea typeface="Segoe UI" pitchFamily="34" charset="-122"/>
+                <a:cs typeface="Segoe UI" pitchFamily="34" charset="-120"/>
+              </a:rPr>
+              <a:t>Nhóm chuyên môn: Toán (T-01/02), Văn (V-01/02), Anh (A-01..03) - môn tự preselect theo phân công</a:t>
+            </a:r>
+            <a:endParaRPr lang="en-US" sz="1350" dirty="0"/>
+          </a:p>
+          <a:p>
+            <a:pPr marL="177800" indent="-177800">
+              <a:spcAft>
+                <a:spcPts val="800"/>
+              </a:spcAft>
+              <a:buSzPct val="100000"/>
+              <a:buChar char="•"/>
+            </a:pPr>
+            <a:r>
+              <a:rPr lang="en-US" sz="1350" b="1" dirty="0">
+                <a:solidFill>
+                  <a:srgbClr val="0F172A"/>
+                </a:solidFill>
+                <a:latin typeface="Segoe UI" pitchFamily="34" charset="0"/>
+                <a:ea typeface="Segoe UI" pitchFamily="34" charset="-122"/>
+                <a:cs typeface="Segoe UI" pitchFamily="34" charset="-120"/>
+              </a:rPr>
+              <a:t>2. DC-02 -&gt; DC-03: ma trận -&gt; đề kiểm tra</a:t>
+            </a:r>
+            <a:endParaRPr lang="en-US" sz="1350" dirty="0"/>
+          </a:p>
+          <a:p>
+            <a:pPr marL="381000" indent="-381000">
+              <a:spcAft>
+                <a:spcPts val="800"/>
+              </a:spcAft>
+              <a:buSzPct val="100000"/>
+              <a:buChar char="–"/>
+            </a:pPr>
+            <a:r>
+              <a:rPr lang="en-US" sz="1200" dirty="0">
+                <a:solidFill>
+                  <a:srgbClr val="475569"/>
+                </a:solidFill>
+                <a:latin typeface="Segoe UI" pitchFamily="34" charset="0"/>
+                <a:ea typeface="Segoe UI" pitchFamily="34" charset="-122"/>
+                <a:cs typeface="Segoe UI" pitchFamily="34" charset="-120"/>
+              </a:rPr>
+              <a:t>Ma trận YCCĐ x mức độ đúng tỷ lệ; đề rút câu từ ngân hàng CỦA TRƯỜNG + đáp án + biên bản phản biện</a:t>
+            </a:r>
+            <a:endParaRPr lang="en-US" sz="1350" dirty="0"/>
+          </a:p>
+          <a:p>
+            <a:pPr marL="177800" indent="-177800">
+              <a:spcAft>
+                <a:spcPts val="800"/>
+              </a:spcAft>
+              <a:buSzPct val="100000"/>
+              <a:buChar char="•"/>
+            </a:pPr>
+            <a:r>
+              <a:rPr lang="en-US" sz="1350" b="1" dirty="0">
+                <a:solidFill>
+                  <a:srgbClr val="0F172A"/>
+                </a:solidFill>
+                <a:latin typeface="Segoe UI" pitchFamily="34" charset="0"/>
+                <a:ea typeface="Segoe UI" pitchFamily="34" charset="-122"/>
+                <a:cs typeface="Segoe UI" pitchFamily="34" charset="-120"/>
+              </a:rPr>
+              <a:t>3. Ngân hàng câu hỏi (/studio/questions)</a:t>
+            </a:r>
+            <a:endParaRPr lang="en-US" sz="1350" dirty="0"/>
+          </a:p>
+          <a:p>
+            <a:pPr marL="381000" indent="-381000">
+              <a:spcAft>
+                <a:spcPts val="800"/>
+              </a:spcAft>
+              <a:buSzPct val="100000"/>
+              <a:buChar char="–"/>
+            </a:pPr>
+            <a:r>
+              <a:rPr lang="en-US" sz="1200" dirty="0">
+                <a:solidFill>
+                  <a:srgbClr val="475569"/>
+                </a:solidFill>
+                <a:latin typeface="Segoe UI" pitchFamily="34" charset="0"/>
+                <a:ea typeface="Segoe UI" pitchFamily="34" charset="-122"/>
+                <a:cs typeface="Segoe UI" pitchFamily="34" charset="-120"/>
+              </a:rPr>
+              <a:t>Đã dọn trùng: mỗi câu gộp đủ YCCĐ, không còn bản lặp; Ngữ văn chỉ khối 6-12 (Tiếng Việt 1-5)</a:t>
+            </a:r>
+            <a:endParaRPr lang="en-US" sz="1350" dirty="0"/>
+          </a:p>
+          <a:p>
+            <a:pPr marL="381000" indent="-381000">
+              <a:spcAft>
+                <a:spcPts val="800"/>
+              </a:spcAft>
+              <a:buSzPct val="100000"/>
+              <a:buChar char="–"/>
+            </a:pPr>
+            <a:r>
+              <a:rPr lang="en-US" sz="1200" dirty="0">
+                <a:solidFill>
+                  <a:srgbClr val="475569"/>
+                </a:solidFill>
+                <a:latin typeface="Segoe UI" pitchFamily="34" charset="0"/>
+                <a:ea typeface="Segoe UI" pitchFamily="34" charset="-122"/>
+                <a:cs typeface="Segoe UI" pitchFamily="34" charset="-120"/>
+              </a:rPr>
+              <a:t>Duyệt 2 lớp: tổ trưởng -&gt; BGH; filter 'Môn của tổ tôi' cho tổ trưởng kiêm nhiệm</a:t>
+            </a:r>
+            <a:endParaRPr lang="en-US" sz="1350" dirty="0"/>
+          </a:p>
+          <a:p>
+            <a:pPr marL="177800" indent="-177800">
+              <a:spcAft>
+                <a:spcPts val="800"/>
+              </a:spcAft>
+              <a:buSzPct val="100000"/>
+              <a:buChar char="•"/>
+            </a:pPr>
+            <a:r>
+              <a:rPr lang="en-US" sz="1350" b="1" dirty="0">
+                <a:solidFill>
+                  <a:srgbClr val="0F172A"/>
+                </a:solidFill>
+                <a:latin typeface="Segoe UI" pitchFamily="34" charset="0"/>
+                <a:ea typeface="Segoe UI" pitchFamily="34" charset="-122"/>
+                <a:cs typeface="Segoe UI" pitchFamily="34" charset="-120"/>
+              </a:rPr>
+              <a:t>4. A-03: hội thoại + bài nghe có AUDIO THẬT</a:t>
+            </a:r>
+            <a:endParaRPr lang="en-US" sz="1350" dirty="0"/>
+          </a:p>
+          <a:p>
+            <a:pPr marL="381000" indent="-381000">
+              <a:spcAft>
+                <a:spcPts val="800"/>
+              </a:spcAft>
+              <a:buSzPct val="100000"/>
+              <a:buChar char="–"/>
+            </a:pPr>
+            <a:r>
+              <a:rPr lang="en-US" sz="1200" dirty="0">
+                <a:solidFill>
+                  <a:srgbClr val="475569"/>
+                </a:solidFill>
+                <a:latin typeface="Segoe UI" pitchFamily="34" charset="0"/>
+                <a:ea typeface="Segoe UI" pitchFamily="34" charset="-122"/>
+                <a:cs typeface="Segoe UI" pitchFamily="34" charset="-120"/>
+              </a:rPr>
+              <a:t>Sinh hội thoại -&gt; audio giọng neural phát ngay (material mẫu 'At the Market' lớp 5, login anhhd@cva.scn)</a:t>
+            </a:r>
+            <a:endParaRPr lang="en-US" sz="1350" dirty="0"/>
+          </a:p>
+          <a:p>
+            <a:pPr marL="177800" indent="-177800">
+              <a:spcAft>
+                <a:spcPts val="800"/>
+              </a:spcAft>
+              <a:buSzPct val="100000"/>
+              <a:buChar char="•"/>
+            </a:pPr>
+            <a:r>
+              <a:rPr lang="en-US" sz="1350" dirty="0">
+                <a:solidFill>
+                  <a:srgbClr val="0F172A"/>
+                </a:solidFill>
+                <a:latin typeface="Segoe UI" pitchFamily="34" charset="0"/>
+                <a:ea typeface="Segoe UI" pitchFamily="34" charset="-122"/>
+                <a:cs typeface="Segoe UI" pitchFamily="34" charset="-120"/>
+              </a:rPr>
+              <a:t>5. Xuất DOCX/PDF/PPTX - học liệu published cả trường xem, nháp chỉ tác giả + người duyệt</a:t>
+            </a:r>
+            <a:endParaRPr lang="en-US" sz="1350" dirty="0"/>
+          </a:p>
+          <a:p>
+            <a:pPr marL="381000" indent="-381000">
+              <a:spcAft>
+                <a:spcPts val="800"/>
+              </a:spcAft>
+              <a:buSzPct val="100000"/>
+              <a:buChar char="–"/>
+            </a:pPr>
+            <a:r>
+              <a:rPr lang="en-US" sz="1200" dirty="0">
+                <a:solidFill>
+                  <a:srgbClr val="475569"/>
+                </a:solidFill>
+                <a:latin typeface="Segoe UI" pitchFamily="34" charset="0"/>
+                <a:ea typeface="Segoe UI" pitchFamily="34" charset="-122"/>
+                <a:cs typeface="Segoe UI" pitchFamily="34" charset="-120"/>
+              </a:rPr>
+              <a:t>AI có kiểm chứng 2 lớp + fallback rule-based khi hết quota - demo không đứng</a:t>
+            </a:r>
+            <a:endParaRPr lang="en-US" sz="1350" dirty="0"/>
+          </a:p>
+        </p:txBody>
+      </p:sp>
+      <p:sp>
+        <p:nvSpPr>
+          <p:cNvPr id="7" name="Text 5"/>
+          <p:cNvSpPr/>
+          <p:nvPr/>
+        </p:nvSpPr>
+        <p:spPr>
+          <a:xfrm>
+            <a:off x="640080" y="6309360"/>
+            <a:ext cx="10972800" cy="457200"/>
+          </a:xfrm>
+          <a:prstGeom prst="rect">
+            <a:avLst/>
+          </a:prstGeom>
+          <a:noFill/>
+          <a:ln/>
+        </p:spPr>
+        <p:txBody>
+          <a:bodyPr wrap="square" rtlCol="0" anchor="ctr"/>
+          <a:lstStyle/>
+          <a:p>
+            <a:pPr indent="0" marL="0">
+              <a:buNone/>
+            </a:pPr>
+            <a:r>
+              <a:rPr lang="en-US" sz="1050" i="1" dirty="0">
+                <a:solidFill>
+                  <a:srgbClr val="0F766E"/>
+                </a:solidFill>
+                <a:latin typeface="Segoe UI" pitchFamily="34" charset="0"/>
+                <a:ea typeface="Segoe UI" pitchFamily="34" charset="-122"/>
+                <a:cs typeface="Segoe UI" pitchFamily="34" charset="-120"/>
+              </a:rPr>
+              <a:t>Thông điệp: giáo viên không cần app thứ hai - soạn, duyệt, xuất ngay trong sổ chủ nhiệm.</a:t>
+            </a:r>
+            <a:endParaRPr lang="en-US" sz="1050" dirty="0"/>
+          </a:p>
+        </p:txBody>
+      </p:sp>
+    </p:spTree>
+  </p:cSld>
+  <p:clrMapOvr>
+    <a:masterClrMapping/>
+  </p:clrMapOvr>
+</p:sld>
+</file>
+
+<file path=ppt/slides/slide13.xml><?xml version="1.0" encoding="utf-8"?>
+<p:sld xmlns:a="http://schemas.openxmlformats.org/drawingml/2006/main" xmlns:r="http://schemas.openxmlformats.org/officeDocument/2006/relationships" xmlns:p="http://schemas.openxmlformats.org/presentationml/2006/main">
+  <p:cSld name="Slide 13">
+    <p:spTree>
+      <p:nvGrpSpPr>
+        <p:cNvPr id="1" name=""/>
+        <p:cNvGrpSpPr/>
+        <p:nvPr/>
+      </p:nvGrpSpPr>
+      <p:grpSpPr>
+        <a:xfrm>
+          <a:off x="0" y="0"/>
+          <a:ext cx="0" cy="0"/>
+          <a:chOff x="0" y="0"/>
+          <a:chExt cx="0" cy="0"/>
+        </a:xfrm>
+      </p:grpSpPr>
+      <p:sp>
+        <p:nvSpPr>
+          <p:cNvPr id="2" name="Text 0"/>
+          <p:cNvSpPr/>
+          <p:nvPr/>
+        </p:nvSpPr>
+        <p:spPr>
+          <a:xfrm>
+            <a:off x="502920" y="256032"/>
+            <a:ext cx="10972800" cy="274320"/>
+          </a:xfrm>
+          <a:prstGeom prst="rect">
+            <a:avLst/>
+          </a:prstGeom>
+          <a:noFill/>
+          <a:ln/>
+        </p:spPr>
+        <p:txBody>
+          <a:bodyPr wrap="square" rtlCol="0" anchor="ctr"/>
+          <a:lstStyle/>
+          <a:p>
+            <a:pPr indent="0" marL="0">
+              <a:buNone/>
+            </a:pPr>
+            <a:r>
+              <a:rPr lang="en-US" sz="1100" b="1" dirty="0">
+                <a:solidFill>
+                  <a:srgbClr val="0F766E"/>
+                </a:solidFill>
+                <a:latin typeface="Segoe UI" pitchFamily="34" charset="0"/>
+                <a:ea typeface="Segoe UI" pitchFamily="34" charset="-122"/>
+                <a:cs typeface="Segoe UI" pitchFamily="34" charset="-120"/>
+              </a:rPr>
               <a:t>KIỂM CHỨNG PHÂN QUYỀN</a:t>
             </a:r>
             <a:endParaRPr lang="en-US" sz="1100" dirty="0"/>
@@ -3150,7 +3717,7 @@
       </p:sp>
       <p:graphicFrame>
         <p:nvGraphicFramePr>
-          <p:cNvPr id="13" name="Table 0"/>
+          <p:cNvPr id="14" name="Table 0"/>
           <p:cNvGraphicFramePr>
             <a:graphicFrameLocks noGrp="1"/>
           </p:cNvGraphicFramePr>
@@ -4668,9 +5235,9 @@
 </p:sld>
 </file>
 
-<file path=ppt/slides/slide13.xml><?xml version="1.0" encoding="utf-8"?>
+<file path=ppt/slides/slide14.xml><?xml version="1.0" encoding="utf-8"?>
 <p:sld xmlns:a="http://schemas.openxmlformats.org/drawingml/2006/main" xmlns:r="http://schemas.openxmlformats.org/officeDocument/2006/relationships" xmlns:p="http://schemas.openxmlformats.org/presentationml/2006/main">
-  <p:cSld name="Slide 13">
+  <p:cSld name="Slide 14">
     <p:spTree>
       <p:nvGrpSpPr>
         <p:cNvPr id="1" name=""/>
@@ -5044,9 +5611,9 @@
 </p:sld>
 </file>
 
-<file path=ppt/slides/slide14.xml><?xml version="1.0" encoding="utf-8"?>
+<file path=ppt/slides/slide15.xml><?xml version="1.0" encoding="utf-8"?>
 <p:sld xmlns:a="http://schemas.openxmlformats.org/drawingml/2006/main" xmlns:r="http://schemas.openxmlformats.org/officeDocument/2006/relationships" xmlns:p="http://schemas.openxmlformats.org/presentationml/2006/main">
-  <p:cSld name="Slide 14">
+  <p:cSld name="Slide 15">
     <p:bg>
       <p:bgPr>
         <a:solidFill>

</xml_diff>